<commit_message>
Photo-led slide 4: crop rows under open sky instead of the hand photo
Co-Authored-By: Claude Sonnet 5.5 <noreply@anthropic.com>
Claude-Session: https://claude.ai/code/session_011Ayydt3bbwxJJGtBUdBGUR
</commit_message>
<xml_diff>
--- a/templates/carousels/photo-led-carousel.pptx
+++ b/templates/carousels/photo-led-carousel.pptx
@@ -716,7 +716,7 @@
           <a:lstStyle/>
           <a:p>
             <a:r>
-              <a:t>Photo: assets/photo/hand-soil-roots-fungi.jpg. Same layout, panels kept to the top third.</a:t>
+              <a:t>Photo: assets/photo/erc-rancho-cacachilas-agro.jpg (crop rows under a wide sky). Panels sit in the sky.</a:t>
             </a:r>
           </a:p>
         </p:txBody>
@@ -3794,7 +3794,7 @@
       <p:grpSpPr/>
       <p:pic>
         <p:nvPicPr>
-          <p:cNvPr id="2" name="Picture 1" descr="3812193197056478006.jpg"/>
+          <p:cNvPr id="2" name="Picture 1" descr="8284748044392281135.jpg"/>
           <p:cNvPicPr>
             <a:picLocks noChangeAspect="1"/>
           </p:cNvPicPr>
@@ -4128,7 +4128,7 @@
       <p:grpSpPr/>
       <p:pic>
         <p:nvPicPr>
-          <p:cNvPr id="2" name="Picture 1" descr="1618727070285903912.jpg"/>
+          <p:cNvPr id="2" name="Picture 1" descr="6680318646487736988.jpg"/>
           <p:cNvPicPr>
             <a:picLocks noChangeAspect="1"/>
           </p:cNvPicPr>
@@ -4462,7 +4462,7 @@
       <p:grpSpPr/>
       <p:pic>
         <p:nvPicPr>
-          <p:cNvPr id="2" name="Picture 1" descr="6832500452447924392.jpg"/>
+          <p:cNvPr id="2" name="Picture 1" descr="8786642421847334262.jpg"/>
           <p:cNvPicPr>
             <a:picLocks noChangeAspect="1"/>
           </p:cNvPicPr>
@@ -4796,7 +4796,7 @@
       <p:grpSpPr/>
       <p:pic>
         <p:nvPicPr>
-          <p:cNvPr id="2" name="Picture 1" descr="7755464671366313149.jpg"/>
+          <p:cNvPr id="2" name="Picture 1" descr="2407834678506028425.jpg"/>
           <p:cNvPicPr>
             <a:picLocks noChangeAspect="1"/>
           </p:cNvPicPr>
@@ -5130,7 +5130,7 @@
       <p:grpSpPr/>
       <p:pic>
         <p:nvPicPr>
-          <p:cNvPr id="2" name="Picture 1" descr="1314624559186166345.jpg"/>
+          <p:cNvPr id="2" name="Picture 1" descr="1765256235290983748.jpg"/>
           <p:cNvPicPr>
             <a:picLocks noChangeAspect="1"/>
           </p:cNvPicPr>

</xml_diff>